<commit_message>
Fix NHS-recognizer false negatives; deploy fix; docs updated to F1 0.6814
- Deregister Presidio's built-in NhsRecognizer: it validates 10-digit sequences against the real NHS checksum and was winning the overlap-resolution slot over genuine US phone numbers, mislabeling them UK_NHS

- Fixes 2 PHONE_NUMBER false negatives found via eval/error_analysis.py; OVERALL F1 (OVERLAP) 0.6619 -> 0.6814, recall now a perfect 2150/2150 spans, zero false negatives

- Report: new Section 6.9, updated Milestone/ablation tables, live demo URL filled in

- Deck: new PART 6 bug slide, updated title-slide stats (F1, bug count 8->9)

- README: NHS fix added to eval narrative, ModuleNotFoundError fix added to Production Roadmap
</commit_message>
<xml_diff>
--- a/Capstone_Presentation.pptx
+++ b/Capstone_Presentation.pptx
@@ -20,6 +20,7 @@
     <p:sldId id="267" r:id="rId13"/>
     <p:sldId id="272" r:id="rId23"/>
     <p:sldId id="273" r:id="rId24"/>
+    <p:sldId id="274" r:id="rId25"/>
     <p:sldId id="268" r:id="rId14"/>
     <p:sldId id="269" r:id="rId15"/>
     <p:sldId id="270" r:id="rId16"/>
@@ -2741,7 +2742,7 @@
                 <a:ea typeface="Cambria" pitchFamily="34" charset="-122"/>
                 <a:cs typeface="Cambria" pitchFamily="34" charset="-120"/>
               </a:rPr>
-              <a:t>0.6619</a:t>
+              <a:t>0.6814</a:t>
             </a:r>
             <a:endParaRPr lang="en-US" sz="3000" dirty="0"/>
           </a:p>
@@ -2819,7 +2820,7 @@
                 <a:ea typeface="Cambria" pitchFamily="34" charset="-122"/>
                 <a:cs typeface="Cambria" pitchFamily="34" charset="-120"/>
               </a:rPr>
-              <a:t>8</a:t>
+              <a:t>9</a:t>
             </a:r>
             <a:endParaRPr lang="en-US" sz="3000" dirty="0"/>
           </a:p>
@@ -5980,7 +5981,7 @@
                 <a:ea typeface="Calibri" pitchFamily="34" charset="-122"/>
                 <a:cs typeface="Calibri" pitchFamily="34" charset="-120"/>
               </a:rPr>
-              <a:t>16</a:t>
+              <a:t>17</a:t>
             </a:r>
             <a:endParaRPr lang="en-US" sz="1000" dirty="0"/>
           </a:p>
@@ -6667,7 +6668,7 @@
                 <a:ea typeface="Calibri" pitchFamily="34" charset="-122"/>
                 <a:cs typeface="Calibri" pitchFamily="34" charset="-120"/>
               </a:rPr>
-              <a:t>17</a:t>
+              <a:t>18</a:t>
             </a:r>
             <a:endParaRPr lang="en-US" sz="1000" dirty="0"/>
           </a:p>
@@ -6875,7 +6876,7 @@
                 <a:ea typeface="Calibri" pitchFamily="34" charset="-122"/>
                 <a:cs typeface="Calibri" pitchFamily="34" charset="-120"/>
               </a:rPr>
-              <a:t>Every evaluation number comes from a real execution of the eval harness — final OVERALL F1 0.6619, recall essentially saturated — not a hand-picked or simulated result.</a:t>
+              <a:t>Every evaluation number comes from a real execution of the eval harness — final OVERALL F1 0.6814, recall fully saturated (2,150 of 2,150 spans) — not a hand-picked or simulated result.</a:t>
             </a:r>
             <a:endParaRPr lang="en-US" sz="1500" dirty="0"/>
           </a:p>
@@ -6973,7 +6974,7 @@
                 <a:ea typeface="Calibri" pitchFamily="34" charset="-122"/>
                 <a:cs typeface="Calibri" pitchFamily="34" charset="-120"/>
               </a:rPr>
-              <a:t>Every one of the eight bugs in this deck was found through genuine debugging, live testing, or systematic error analysis, and confirmed fixed with real evidence.</a:t>
+              <a:t>Every one of the nine bugs in this deck was found through genuine debugging, live testing, or systematic error analysis, and confirmed fixed with real evidence.</a:t>
             </a:r>
             <a:endParaRPr lang="en-US" sz="1500" dirty="0"/>
           </a:p>
@@ -9328,6 +9329,500 @@
                 <a:cs typeface="Calibri" pitchFamily="34" charset="-120"/>
               </a:rPr>
               <a:t>15</a:t>
+            </a:r>
+            <a:endParaRPr lang="en-US" sz="1000" dirty="0"/>
+          </a:p>
+        </p:txBody>
+      </p:sp>
+    </p:spTree>
+  </p:cSld>
+  <p:clrMapOvr>
+    <a:masterClrMapping/>
+  </p:clrMapOvr>
+</p:sld>
+</file>
+
+<file path=ppt/slides/slide19.xml><?xml version="1.0" encoding="utf-8"?>
+<p:sld xmlns:a="http://schemas.openxmlformats.org/drawingml/2006/main" xmlns:r="http://schemas.openxmlformats.org/officeDocument/2006/relationships" xmlns:p="http://schemas.openxmlformats.org/presentationml/2006/main">
+  <p:cSld name="Slide 19">
+    <p:bg>
+      <p:bgPr>
+        <a:solidFill>
+          <a:srgbClr val="FFFFFF"/>
+        </a:solidFill>
+      </p:bgPr>
+    </p:bg>
+    <p:spTree>
+      <p:nvGrpSpPr>
+        <p:cNvPr id="1" name=""/>
+        <p:cNvGrpSpPr/>
+        <p:nvPr/>
+      </p:nvGrpSpPr>
+      <p:grpSpPr>
+        <a:xfrm>
+          <a:off x="0" y="0"/>
+          <a:ext cx="0" cy="0"/>
+          <a:chOff x="0" y="0"/>
+          <a:chExt cx="0" cy="0"/>
+        </a:xfrm>
+      </p:grpSpPr>
+      <p:sp>
+        <p:nvSpPr>
+          <p:cNvPr id="2" name="Text 0"/>
+          <p:cNvSpPr/>
+          <p:nvPr/>
+        </p:nvSpPr>
+        <p:spPr>
+          <a:xfrm>
+            <a:off x="548640" y="365760"/>
+            <a:ext cx="7315200" cy="320040"/>
+          </a:xfrm>
+          <a:prstGeom prst="rect">
+            <a:avLst/>
+          </a:prstGeom>
+          <a:noFill/>
+          <a:ln/>
+        </p:spPr>
+        <p:txBody>
+          <a:bodyPr wrap="square" rtlCol="0" anchor="ctr"/>
+          <a:lstStyle/>
+          <a:p>
+            <a:pPr indent="0" marL="0">
+              <a:buNone/>
+            </a:pPr>
+            <a:r>
+              <a:rPr lang="en-US" sz="1200" b="1" spc="200" kern="0" dirty="0">
+                <a:solidFill>
+                  <a:srgbClr val="0F6E56"/>
+                </a:solidFill>
+                <a:latin typeface="Calibri" pitchFamily="34" charset="0"/>
+                <a:ea typeface="Calibri" pitchFamily="34" charset="-122"/>
+                <a:cs typeface="Calibri" pitchFamily="34" charset="-120"/>
+              </a:rPr>
+              <a:t>REAL BUGS FOUND &amp; FIXED — PART 6</a:t>
+            </a:r>
+            <a:endParaRPr lang="en-US" sz="1200" dirty="0"/>
+          </a:p>
+        </p:txBody>
+      </p:sp>
+      <p:sp>
+        <p:nvSpPr>
+          <p:cNvPr id="3" name="Text 1"/>
+          <p:cNvSpPr/>
+          <p:nvPr/>
+        </p:nvSpPr>
+        <p:spPr>
+          <a:xfrm>
+            <a:off x="548640" y="640080"/>
+            <a:ext cx="11064240" cy="822960"/>
+          </a:xfrm>
+          <a:prstGeom prst="rect">
+            <a:avLst/>
+          </a:prstGeom>
+          <a:noFill/>
+          <a:ln/>
+        </p:spPr>
+        <p:txBody>
+          <a:bodyPr wrap="square" rtlCol="0" anchor="ctr"/>
+          <a:lstStyle/>
+          <a:p>
+            <a:pPr algn="l" indent="0" marL="0">
+              <a:buNone/>
+            </a:pPr>
+            <a:r>
+              <a:rPr lang="en-US" sz="3000" b="1" dirty="0">
+                <a:solidFill>
+                  <a:srgbClr val="1F4E79"/>
+                </a:solidFill>
+                <a:latin typeface="Cambria" pitchFamily="34" charset="0"/>
+                <a:ea typeface="Cambria" pitchFamily="34" charset="-122"/>
+                <a:cs typeface="Cambria" pitchFamily="34" charset="-120"/>
+              </a:rPr>
+              <a:t>Found via eval error analysis after the first live Streamlit Cloud deployment</a:t>
+            </a:r>
+            <a:endParaRPr lang="en-US" sz="3000" dirty="0"/>
+          </a:p>
+        </p:txBody>
+      </p:sp>
+      <p:sp>
+        <p:nvSpPr>
+          <p:cNvPr id="4" name="Shape 2"/>
+          <p:cNvSpPr/>
+          <p:nvPr/>
+        </p:nvSpPr>
+        <p:spPr>
+          <a:xfrm>
+            <a:off x="548640" y="1691640"/>
+            <a:ext cx="11064240" cy="1965960"/>
+          </a:xfrm>
+          <a:prstGeom prst="roundRect">
+            <a:avLst>
+              <a:gd name="adj" fmla="val 3721"/>
+            </a:avLst>
+          </a:prstGeom>
+          <a:solidFill>
+            <a:srgbClr val="F7F9FB"/>
+          </a:solidFill>
+          <a:ln w="12700">
+            <a:solidFill>
+              <a:srgbClr val="E3E8EC"/>
+            </a:solidFill>
+            <a:prstDash val="solid"/>
+          </a:ln>
+          <a:effectLst>
+            <a:outerShdw sx="100000" sy="100000" kx="0" ky="0" algn="bl" rotWithShape="0" blurRad="76200" dist="25400" dir="5400000">
+              <a:srgbClr val="999999">
+                <a:alpha val="18000"/>
+              </a:srgbClr>
+            </a:outerShdw>
+          </a:effectLst>
+        </p:spPr>
+      </p:sp>
+      <p:sp>
+        <p:nvSpPr>
+          <p:cNvPr id="5" name="Shape 3"/>
+          <p:cNvSpPr/>
+          <p:nvPr/>
+        </p:nvSpPr>
+        <p:spPr>
+          <a:xfrm>
+            <a:off x="822960" y="1965960"/>
+            <a:ext cx="457200" cy="457200"/>
+          </a:xfrm>
+          <a:prstGeom prst="ellipse">
+            <a:avLst/>
+          </a:prstGeom>
+          <a:solidFill>
+            <a:srgbClr val="993C1D"/>
+          </a:solidFill>
+          <a:ln/>
+        </p:spPr>
+      </p:sp>
+      <p:sp>
+        <p:nvSpPr>
+          <p:cNvPr id="6" name="Text 4"/>
+          <p:cNvSpPr/>
+          <p:nvPr/>
+        </p:nvSpPr>
+        <p:spPr>
+          <a:xfrm>
+            <a:off x="822960" y="1965960"/>
+            <a:ext cx="457200" cy="457200"/>
+          </a:xfrm>
+          <a:prstGeom prst="rect">
+            <a:avLst/>
+          </a:prstGeom>
+          <a:noFill/>
+          <a:ln/>
+        </p:spPr>
+        <p:txBody>
+          <a:bodyPr wrap="square" rtlCol="0" anchor="ctr"/>
+          <a:lstStyle/>
+          <a:p>
+            <a:pPr algn="ctr" indent="0" marL="0">
+              <a:buNone/>
+            </a:pPr>
+            <a:r>
+              <a:rPr lang="en-US" sz="1600" b="1" dirty="0">
+                <a:solidFill>
+                  <a:srgbClr val="FFFFFF"/>
+                </a:solidFill>
+                <a:latin typeface="Cambria" pitchFamily="34" charset="0"/>
+                <a:ea typeface="Cambria" pitchFamily="34" charset="-122"/>
+                <a:cs typeface="Cambria" pitchFamily="34" charset="-120"/>
+              </a:rPr>
+              <a:t>9</a:t>
+            </a:r>
+            <a:endParaRPr lang="en-US" sz="1600" dirty="0"/>
+          </a:p>
+        </p:txBody>
+      </p:sp>
+      <p:sp>
+        <p:nvSpPr>
+          <p:cNvPr id="7" name="Shape 5"/>
+          <p:cNvSpPr/>
+          <p:nvPr/>
+        </p:nvSpPr>
+        <p:spPr>
+          <a:xfrm>
+            <a:off x="1463040" y="2011680"/>
+            <a:ext cx="3017520" cy="365760"/>
+          </a:xfrm>
+          <a:prstGeom prst="roundRect">
+            <a:avLst>
+              <a:gd name="adj" fmla="val 15000"/>
+            </a:avLst>
+          </a:prstGeom>
+          <a:solidFill>
+            <a:srgbClr val="FAEEDA"/>
+          </a:solidFill>
+          <a:ln/>
+        </p:spPr>
+      </p:sp>
+      <p:sp>
+        <p:nvSpPr>
+          <p:cNvPr id="8" name="Text 6"/>
+          <p:cNvSpPr/>
+          <p:nvPr/>
+        </p:nvSpPr>
+        <p:spPr>
+          <a:xfrm>
+            <a:off x="1463040" y="2011680"/>
+            <a:ext cx="3017520" cy="365760"/>
+          </a:xfrm>
+          <a:prstGeom prst="rect">
+            <a:avLst/>
+          </a:prstGeom>
+          <a:noFill/>
+          <a:ln/>
+        </p:spPr>
+        <p:txBody>
+          <a:bodyPr wrap="square" rtlCol="0" anchor="ctr"/>
+          <a:lstStyle/>
+          <a:p>
+            <a:pPr algn="ctr" indent="0" marL="0">
+              <a:buNone/>
+            </a:pPr>
+            <a:r>
+              <a:rPr lang="en-US" sz="1000" b="1" dirty="0">
+                <a:solidFill>
+                  <a:srgbClr val="7A4D08"/>
+                </a:solidFill>
+                <a:latin typeface="Calibri" pitchFamily="34" charset="0"/>
+                <a:ea typeface="Calibri" pitchFamily="34" charset="-122"/>
+                <a:cs typeface="Calibri" pitchFamily="34" charset="-120"/>
+              </a:rPr>
+              <a:t>IRRELEVANT RECOGNIZER COLLISION</a:t>
+            </a:r>
+            <a:endParaRPr lang="en-US" sz="1000" dirty="0"/>
+          </a:p>
+        </p:txBody>
+      </p:sp>
+      <p:sp>
+        <p:nvSpPr>
+          <p:cNvPr id="9" name="Text 7"/>
+          <p:cNvSpPr/>
+          <p:nvPr/>
+        </p:nvSpPr>
+        <p:spPr>
+          <a:xfrm>
+            <a:off x="822960" y="2514600"/>
+            <a:ext cx="10424160" cy="457200"/>
+          </a:xfrm>
+          <a:prstGeom prst="rect">
+            <a:avLst/>
+          </a:prstGeom>
+          <a:noFill/>
+          <a:ln/>
+        </p:spPr>
+        <p:txBody>
+          <a:bodyPr wrap="square" rtlCol="0" anchor="ctr"/>
+          <a:lstStyle/>
+          <a:p>
+            <a:pPr indent="0" marL="0">
+              <a:buNone/>
+            </a:pPr>
+            <a:r>
+              <a:rPr lang="en-US" sz="1500" b="1" dirty="0">
+                <a:solidFill>
+                  <a:srgbClr val="1A1A18"/>
+                </a:solidFill>
+                <a:latin typeface="Cambria" pitchFamily="34" charset="0"/>
+                <a:ea typeface="Cambria" pitchFamily="34" charset="-122"/>
+                <a:cs typeface="Cambria" pitchFamily="34" charset="-120"/>
+              </a:rPr>
+              <a:t>Two ordinary US phone numbers silently mislabeled as UK NHS numbers</a:t>
+            </a:r>
+            <a:endParaRPr lang="en-US" sz="1500" dirty="0"/>
+          </a:p>
+        </p:txBody>
+      </p:sp>
+      <p:sp>
+        <p:nvSpPr>
+          <p:cNvPr id="10" name="Text 8"/>
+          <p:cNvSpPr/>
+          <p:nvPr/>
+        </p:nvSpPr>
+        <p:spPr>
+          <a:xfrm>
+            <a:off x="822960" y="2971800"/>
+            <a:ext cx="10424160" cy="640080"/>
+          </a:xfrm>
+          <a:prstGeom prst="rect">
+            <a:avLst/>
+          </a:prstGeom>
+          <a:noFill/>
+          <a:ln/>
+        </p:spPr>
+        <p:txBody>
+          <a:bodyPr wrap="square" rtlCol="0" anchor="ctr"/>
+          <a:lstStyle/>
+          <a:p>
+            <a:pPr indent="0" marL="0">
+              <a:buNone/>
+            </a:pPr>
+            <a:r>
+              <a:rPr lang="en-US" sz="1150" dirty="0">
+                <a:solidFill>
+                  <a:srgbClr val="5F5E5A"/>
+                </a:solidFill>
+                <a:latin typeface="Calibri" pitchFamily="34" charset="0"/>
+                <a:ea typeface="Calibri" pitchFamily="34" charset="-122"/>
+                <a:cs typeface="Calibri" pitchFamily="34" charset="-120"/>
+              </a:rPr>
+              <a:t>Presidio ships a built-in NhsRecognizer (UK NHS number recognizer) that validates any 10-digit sequence against the real NHS Mod-11 checksum and returns a perfect 1.0 confidence, no UK context needed. Two ordinary US phone numbers happened to pass that checksum, so the NHS candidate beat this project's own PHONE_NUMBER detections in the overlap-resolution step — the span was still redacted (no PHI leak), just mislabeled.</a:t>
+            </a:r>
+            <a:endParaRPr lang="en-US" sz="1150" dirty="0"/>
+          </a:p>
+        </p:txBody>
+      </p:sp>
+      <p:sp>
+        <p:nvSpPr>
+          <p:cNvPr id="11" name="Shape 9"/>
+          <p:cNvSpPr/>
+          <p:nvPr/>
+        </p:nvSpPr>
+        <p:spPr>
+          <a:xfrm>
+            <a:off x="548640" y="3840480"/>
+            <a:ext cx="11064240" cy="1691640"/>
+          </a:xfrm>
+          <a:prstGeom prst="roundRect">
+            <a:avLst>
+              <a:gd name="adj" fmla="val 4324"/>
+            </a:avLst>
+          </a:prstGeom>
+          <a:solidFill>
+            <a:srgbClr val="E1F5EE"/>
+          </a:solidFill>
+          <a:ln w="12700">
+            <a:solidFill>
+              <a:srgbClr val="E1F5EE"/>
+            </a:solidFill>
+            <a:prstDash val="solid"/>
+          </a:ln>
+        </p:spPr>
+      </p:sp>
+      <p:sp>
+        <p:nvSpPr>
+          <p:cNvPr id="12" name="Text 10"/>
+          <p:cNvSpPr/>
+          <p:nvPr/>
+        </p:nvSpPr>
+        <p:spPr>
+          <a:xfrm>
+            <a:off x="822960" y="4023360"/>
+            <a:ext cx="10515600" cy="822960"/>
+          </a:xfrm>
+          <a:prstGeom prst="rect">
+            <a:avLst/>
+          </a:prstGeom>
+          <a:noFill/>
+          <a:ln/>
+        </p:spPr>
+        <p:txBody>
+          <a:bodyPr wrap="square" rtlCol="0" anchor="t"/>
+          <a:lstStyle/>
+          <a:p>
+            <a:pPr indent="0" marL="0">
+              <a:buNone/>
+            </a:pPr>
+            <a:r>
+              <a:rPr lang="en-US" sz="1300" b="1" dirty="0">
+                <a:solidFill>
+                  <a:srgbClr val="0F6E56"/>
+                </a:solidFill>
+              </a:rPr>
+              <a:t>Fix: </a:t>
+            </a:r>
+            <a:pPr indent="0" marL="0">
+              <a:buNone/>
+            </a:pPr>
+            <a:r>
+              <a:rPr lang="en-US" sz="1250" dirty="0">
+                <a:solidFill>
+                  <a:srgbClr val="0D5040"/>
+                </a:solidFill>
+              </a:rPr>
+              <a:t>Deregistered NhsRecognizer from the analyzer registry — same pattern already used to remove the irrelevant US_DRIVER_LICENSE recognizer, since neither is relevant to this project's all-US clinical documents.</a:t>
+            </a:r>
+            <a:endParaRPr lang="en-US" sz="1300" dirty="0"/>
+          </a:p>
+        </p:txBody>
+      </p:sp>
+      <p:sp>
+        <p:nvSpPr>
+          <p:cNvPr id="13" name="Text 11"/>
+          <p:cNvSpPr/>
+          <p:nvPr/>
+        </p:nvSpPr>
+        <p:spPr>
+          <a:xfrm>
+            <a:off x="822960" y="4937760"/>
+            <a:ext cx="10515600" cy="457200"/>
+          </a:xfrm>
+          <a:prstGeom prst="rect">
+            <a:avLst/>
+          </a:prstGeom>
+          <a:noFill/>
+          <a:ln/>
+        </p:spPr>
+        <p:txBody>
+          <a:bodyPr wrap="square" rtlCol="0" anchor="ctr"/>
+          <a:lstStyle/>
+          <a:p>
+            <a:pPr indent="0" marL="0">
+              <a:buNone/>
+            </a:pPr>
+            <a:r>
+              <a:rPr lang="en-US" sz="1250" b="1" dirty="0">
+                <a:solidFill>
+                  <a:srgbClr val="0D5040"/>
+                </a:solidFill>
+                <a:latin typeface="Calibri" pitchFamily="34" charset="0"/>
+                <a:ea typeface="Calibri" pitchFamily="34" charset="-122"/>
+                <a:cs typeface="Calibri" pitchFamily="34" charset="-120"/>
+              </a:rPr>
+              <a:t>OVERALL F1 improved 0.6619 → 0.6814, recall reached a perfect 2,150/2,150 labeled spans (zero false negatives) — confirmed by re-running the full eval suite. 57/57 tests still pass.</a:t>
+            </a:r>
+            <a:endParaRPr lang="en-US" sz="1250" dirty="0"/>
+          </a:p>
+        </p:txBody>
+      </p:sp>
+      <p:sp>
+        <p:nvSpPr>
+          <p:cNvPr id="14" name="Text 12"/>
+          <p:cNvSpPr/>
+          <p:nvPr/>
+        </p:nvSpPr>
+        <p:spPr>
+          <a:xfrm>
+            <a:off x="11612880" y="6492240"/>
+            <a:ext cx="457200" cy="274320"/>
+          </a:xfrm>
+          <a:prstGeom prst="rect">
+            <a:avLst/>
+          </a:prstGeom>
+          <a:noFill/>
+          <a:ln/>
+        </p:spPr>
+        <p:txBody>
+          <a:bodyPr wrap="square" rtlCol="0" anchor="ctr"/>
+          <a:lstStyle/>
+          <a:p>
+            <a:pPr algn="r" indent="0" marL="0">
+              <a:buNone/>
+            </a:pPr>
+            <a:r>
+              <a:rPr lang="en-US" sz="1000" dirty="0">
+                <a:solidFill>
+                  <a:srgbClr val="5F5E5A"/>
+                </a:solidFill>
+                <a:latin typeface="Calibri" pitchFamily="34" charset="0"/>
+                <a:ea typeface="Calibri" pitchFamily="34" charset="-122"/>
+                <a:cs typeface="Calibri" pitchFamily="34" charset="-120"/>
+              </a:rPr>
+              <a:t>16</a:t>
             </a:r>
             <a:endParaRPr lang="en-US" sz="1000" dirty="0"/>
           </a:p>

</xml_diff>